<commit_message>
Update demo slide for notebook workflow
</commit_message>
<xml_diff>
--- a/deliverables/presentation_revised.pptx
+++ b/deliverables/presentation_revised.pptx
@@ -797,7 +797,7 @@
           <a:lstStyle xmlns:a="http://schemas.openxmlformats.org/drawingml/2006/main"/>
           <a:p xmlns:a="http://schemas.openxmlformats.org/drawingml/2006/main">
             <a:r>
-              <a:t>Interpret the accuracy difference carefully: this project's data, features, temporal validation, and safeguards differ from the senior reference's reported 2019 result. The evaluation can be rerun from the single Python file and the annual source CSVs in data/.</a:t>
+              <a:t>Demo: Open tennis_match_prediction.ipynb, select the project .venv Python kernel, and run cells in order. The initial model chart appears after the initial-model cell, the tuning plot after the tuning cell, and the final 2024 evaluation plots after evaluation. Explain feature history and the 14-day gap.</a:t>
             </a:r>
           </a:p>
         </p:txBody>
@@ -4953,7 +4953,7 @@
                 <a:ea typeface="Arial"/>
                 <a:cs typeface="Arial"/>
               </a:rPr>
-              <a:t>Run: python tennis_match_prediction.py</a:t>
+              <a:t>Open tennis_match_prediction.ipynb.</a:t>
             </a:r>
           </a:p>
           <a:p xmlns:a="http://schemas.openxmlformats.org/drawingml/2006/main">
@@ -4977,7 +4977,7 @@
                 <a:ea typeface="Arial"/>
                 <a:cs typeface="Arial"/>
               </a:rPr>
-              <a:t>Show the 2022 tuning table and 2024 metrics.</a:t>
+              <a:t>Select the project's Python kernel and run cells in order.</a:t>
             </a:r>
           </a:p>
           <a:p xmlns:a="http://schemas.openxmlformats.org/drawingml/2006/main">
@@ -5001,7 +5001,7 @@
                 <a:ea typeface="Arial"/>
                 <a:cs typeface="Arial"/>
               </a:rPr>
-              <a:t>Explain the feature history and 14-day gap.</a:t>
+              <a:t>Charts appear below each stage; explain features and the 14-day gap.</a:t>
             </a:r>
           </a:p>
         </p:txBody>

</xml_diff>